<commit_message>
Remove Germany from dataset; keep EU only across report and dashboard.
Dataset now has 19 jurisdictions. Regenerated PDF, figures, country profiles, presentation, and dashboard content.

Co-authored-by: Cursor <cursoragent@cursor.com>
</commit_message>
<xml_diff>
--- a/AI_Clinic_Presentation.pptx
+++ b/AI_Clinic_Presentation.pptx
@@ -3692,7 +3692,7 @@
               </a:defRPr>
             </a:pPr>
             <a:r>
-              <a:t>Mean of seven theme scores. EU / Germany / United States lead; Kenya and Nigeria trail  -  capacity gap at a glance.</a:t>
+              <a:t>Mean of seven theme scores. EU / United States lead; Kenya and Nigeria trail  -  capacity gap at a glance.</a:t>
             </a:r>
           </a:p>
         </p:txBody>
@@ -6127,7 +6127,7 @@
               </a:defRPr>
             </a:pPr>
             <a:r>
-              <a:t>Germany</a:t>
+              <a:t>United States</a:t>
             </a:r>
           </a:p>
         </p:txBody>
@@ -6182,7 +6182,7 @@
               </a:defRPr>
             </a:pPr>
             <a:r>
-              <a:t>8.7</a:t>
+              <a:t>7.6</a:t>
             </a:r>
           </a:p>
         </p:txBody>
@@ -6237,7 +6237,7 @@
               </a:defRPr>
             </a:pPr>
             <a:r>
-              <a:t>10</a:t>
+              <a:t>8</a:t>
             </a:r>
           </a:p>
         </p:txBody>
@@ -6402,7 +6402,7 @@
               </a:defRPr>
             </a:pPr>
             <a:r>
-              <a:t>8</a:t>
+              <a:t>6</a:t>
             </a:r>
           </a:p>
         </p:txBody>
@@ -6457,7 +6457,7 @@
               </a:defRPr>
             </a:pPr>
             <a:r>
-              <a:t>9</a:t>
+              <a:t>6</a:t>
             </a:r>
           </a:p>
         </p:txBody>
@@ -6512,7 +6512,7 @@
               </a:defRPr>
             </a:pPr>
             <a:r>
-              <a:t>9</a:t>
+              <a:t>8</a:t>
             </a:r>
           </a:p>
         </p:txBody>
@@ -6677,7 +6677,7 @@
               </a:defRPr>
             </a:pPr>
             <a:r>
-              <a:t>United States</a:t>
+              <a:t>United Kingdom</a:t>
             </a:r>
           </a:p>
         </p:txBody>
@@ -6732,7 +6732,7 @@
               </a:defRPr>
             </a:pPr>
             <a:r>
-              <a:t>7.6</a:t>
+              <a:t>7.1</a:t>
             </a:r>
           </a:p>
         </p:txBody>
@@ -6842,7 +6842,7 @@
               </a:defRPr>
             </a:pPr>
             <a:r>
-              <a:t>9</a:t>
+              <a:t>8</a:t>
             </a:r>
           </a:p>
         </p:txBody>
@@ -6897,7 +6897,7 @@
               </a:defRPr>
             </a:pPr>
             <a:r>
-              <a:t>9</a:t>
+              <a:t>7</a:t>
             </a:r>
           </a:p>
         </p:txBody>
@@ -6952,7 +6952,7 @@
               </a:defRPr>
             </a:pPr>
             <a:r>
-              <a:t>6</a:t>
+              <a:t>7</a:t>
             </a:r>
           </a:p>
         </p:txBody>
@@ -7007,7 +7007,7 @@
               </a:defRPr>
             </a:pPr>
             <a:r>
-              <a:t>6</a:t>
+              <a:t>7</a:t>
             </a:r>
           </a:p>
         </p:txBody>
@@ -7062,7 +7062,7 @@
               </a:defRPr>
             </a:pPr>
             <a:r>
-              <a:t>8</a:t>
+              <a:t>7</a:t>
             </a:r>
           </a:p>
         </p:txBody>
@@ -7117,7 +7117,7 @@
               </a:defRPr>
             </a:pPr>
             <a:r>
-              <a:t>7</a:t>
+              <a:t>6</a:t>
             </a:r>
           </a:p>
         </p:txBody>
@@ -7227,7 +7227,7 @@
               </a:defRPr>
             </a:pPr>
             <a:r>
-              <a:t>United Kingdom</a:t>
+              <a:t>Canada</a:t>
             </a:r>
           </a:p>
         </p:txBody>
@@ -7337,7 +7337,7 @@
               </a:defRPr>
             </a:pPr>
             <a:r>
-              <a:t>8</a:t>
+              <a:t>7</a:t>
             </a:r>
           </a:p>
         </p:txBody>
@@ -7447,7 +7447,7 @@
               </a:defRPr>
             </a:pPr>
             <a:r>
-              <a:t>7</a:t>
+              <a:t>8</a:t>
             </a:r>
           </a:p>
         </p:txBody>
@@ -7777,7 +7777,7 @@
               </a:defRPr>
             </a:pPr>
             <a:r>
-              <a:t>Canada</a:t>
+              <a:t>Japan</a:t>
             </a:r>
           </a:p>
         </p:txBody>
@@ -7832,7 +7832,7 @@
               </a:defRPr>
             </a:pPr>
             <a:r>
-              <a:t>7.1</a:t>
+              <a:t>7.0</a:t>
             </a:r>
           </a:p>
         </p:txBody>
@@ -8052,7 +8052,7 @@
               </a:defRPr>
             </a:pPr>
             <a:r>
-              <a:t>7</a:t>
+              <a:t>6</a:t>
             </a:r>
           </a:p>
         </p:txBody>
@@ -8162,7 +8162,7 @@
               </a:defRPr>
             </a:pPr>
             <a:r>
-              <a:t>7</a:t>
+              <a:t>8</a:t>
             </a:r>
           </a:p>
         </p:txBody>
@@ -8217,7 +8217,7 @@
               </a:defRPr>
             </a:pPr>
             <a:r>
-              <a:t>6</a:t>
+              <a:t>5</a:t>
             </a:r>
           </a:p>
         </p:txBody>
@@ -8327,7 +8327,7 @@
               </a:defRPr>
             </a:pPr>
             <a:r>
-              <a:t>Japan</a:t>
+              <a:t>Singapore</a:t>
             </a:r>
           </a:p>
         </p:txBody>
@@ -8382,7 +8382,7 @@
               </a:defRPr>
             </a:pPr>
             <a:r>
-              <a:t>7.0</a:t>
+              <a:t>6.9</a:t>
             </a:r>
           </a:p>
         </p:txBody>
@@ -8492,7 +8492,7 @@
               </a:defRPr>
             </a:pPr>
             <a:r>
-              <a:t>8</a:t>
+              <a:t>7</a:t>
             </a:r>
           </a:p>
         </p:txBody>
@@ -8547,7 +8547,7 @@
               </a:defRPr>
             </a:pPr>
             <a:r>
-              <a:t>8</a:t>
+              <a:t>7</a:t>
             </a:r>
           </a:p>
         </p:txBody>
@@ -8602,7 +8602,7 @@
               </a:defRPr>
             </a:pPr>
             <a:r>
-              <a:t>6</a:t>
+              <a:t>8</a:t>
             </a:r>
           </a:p>
         </p:txBody>
@@ -8657,7 +8657,7 @@
               </a:defRPr>
             </a:pPr>
             <a:r>
-              <a:t>7</a:t>
+              <a:t>8</a:t>
             </a:r>
           </a:p>
         </p:txBody>
@@ -8712,7 +8712,7 @@
               </a:defRPr>
             </a:pPr>
             <a:r>
-              <a:t>8</a:t>
+              <a:t>6</a:t>
             </a:r>
           </a:p>
         </p:txBody>
@@ -8877,7 +8877,7 @@
               </a:defRPr>
             </a:pPr>
             <a:r>
-              <a:t>Singapore</a:t>
+              <a:t>Switzerland</a:t>
             </a:r>
           </a:p>
         </p:txBody>
@@ -8987,7 +8987,7 @@
               </a:defRPr>
             </a:pPr>
             <a:r>
-              <a:t>7</a:t>
+              <a:t>8</a:t>
             </a:r>
           </a:p>
         </p:txBody>
@@ -9042,7 +9042,7 @@
               </a:defRPr>
             </a:pPr>
             <a:r>
-              <a:t>7</a:t>
+              <a:t>8</a:t>
             </a:r>
           </a:p>
         </p:txBody>
@@ -9097,7 +9097,7 @@
               </a:defRPr>
             </a:pPr>
             <a:r>
-              <a:t>7</a:t>
+              <a:t>8</a:t>
             </a:r>
           </a:p>
         </p:txBody>
@@ -9152,7 +9152,7 @@
               </a:defRPr>
             </a:pPr>
             <a:r>
-              <a:t>8</a:t>
+              <a:t>6</a:t>
             </a:r>
           </a:p>
         </p:txBody>
@@ -9207,7 +9207,7 @@
               </a:defRPr>
             </a:pPr>
             <a:r>
-              <a:t>8</a:t>
+              <a:t>6</a:t>
             </a:r>
           </a:p>
         </p:txBody>
@@ -9262,7 +9262,7 @@
               </a:defRPr>
             </a:pPr>
             <a:r>
-              <a:t>6</a:t>
+              <a:t>7</a:t>
             </a:r>
           </a:p>
         </p:txBody>
@@ -9427,7 +9427,7 @@
               </a:defRPr>
             </a:pPr>
             <a:r>
-              <a:t>Switzerland</a:t>
+              <a:t>China</a:t>
             </a:r>
           </a:p>
         </p:txBody>
@@ -9482,7 +9482,7 @@
               </a:defRPr>
             </a:pPr>
             <a:r>
-              <a:t>6.9</a:t>
+              <a:t>6.7</a:t>
             </a:r>
           </a:p>
         </p:txBody>
@@ -9537,7 +9537,7 @@
               </a:defRPr>
             </a:pPr>
             <a:r>
-              <a:t>8</a:t>
+              <a:t>7</a:t>
             </a:r>
           </a:p>
         </p:txBody>
@@ -9592,7 +9592,7 @@
               </a:defRPr>
             </a:pPr>
             <a:r>
-              <a:t>8</a:t>
+              <a:t>7</a:t>
             </a:r>
           </a:p>
         </p:txBody>
@@ -9647,7 +9647,7 @@
               </a:defRPr>
             </a:pPr>
             <a:r>
-              <a:t>8</a:t>
+              <a:t>7</a:t>
             </a:r>
           </a:p>
         </p:txBody>
@@ -9702,7 +9702,7 @@
               </a:defRPr>
             </a:pPr>
             <a:r>
-              <a:t>6</a:t>
+              <a:t>7</a:t>
             </a:r>
           </a:p>
         </p:txBody>
@@ -9867,7 +9867,7 @@
               </a:defRPr>
             </a:pPr>
             <a:r>
-              <a:t>5</a:t>
+              <a:t>6</a:t>
             </a:r>
           </a:p>
         </p:txBody>
@@ -9977,7 +9977,7 @@
               </a:defRPr>
             </a:pPr>
             <a:r>
-              <a:t>China</a:t>
+              <a:t>Australia</a:t>
             </a:r>
           </a:p>
         </p:txBody>
@@ -10032,7 +10032,7 @@
               </a:defRPr>
             </a:pPr>
             <a:r>
-              <a:t>6.7</a:t>
+              <a:t>6.6</a:t>
             </a:r>
           </a:p>
         </p:txBody>
@@ -10252,7 +10252,7 @@
               </a:defRPr>
             </a:pPr>
             <a:r>
-              <a:t>7</a:t>
+              <a:t>6</a:t>
             </a:r>
           </a:p>
         </p:txBody>
@@ -10307,7 +10307,7 @@
               </a:defRPr>
             </a:pPr>
             <a:r>
-              <a:t>6</a:t>
+              <a:t>7</a:t>
             </a:r>
           </a:p>
         </p:txBody>
@@ -10417,7 +10417,7 @@
               </a:defRPr>
             </a:pPr>
             <a:r>
-              <a:t>6</a:t>
+              <a:t>5</a:t>
             </a:r>
           </a:p>
         </p:txBody>
@@ -10472,7 +10472,7 @@
               </a:defRPr>
             </a:pPr>
             <a:r>
-              <a:t>Advanced</a:t>
+              <a:t>Moderate</a:t>
             </a:r>
           </a:p>
         </p:txBody>
@@ -10527,7 +10527,7 @@
               </a:defRPr>
             </a:pPr>
             <a:r>
-              <a:t>Australia</a:t>
+              <a:t>South Korea</a:t>
             </a:r>
           </a:p>
         </p:txBody>
@@ -10747,7 +10747,7 @@
               </a:defRPr>
             </a:pPr>
             <a:r>
-              <a:t>7</a:t>
+              <a:t>8</a:t>
             </a:r>
           </a:p>
         </p:txBody>
@@ -10857,7 +10857,7 @@
               </a:defRPr>
             </a:pPr>
             <a:r>
-              <a:t>7</a:t>
+              <a:t>6</a:t>
             </a:r>
           </a:p>
         </p:txBody>
@@ -11022,7 +11022,7 @@
               </a:defRPr>
             </a:pPr>
             <a:r>
-              <a:t>Moderate</a:t>
+              <a:t>Advanced</a:t>
             </a:r>
           </a:p>
         </p:txBody>
@@ -11077,7 +11077,7 @@
               </a:defRPr>
             </a:pPr>
             <a:r>
-              <a:t>South Korea</a:t>
+              <a:t>Israel</a:t>
             </a:r>
           </a:p>
         </p:txBody>
@@ -11132,7 +11132,7 @@
               </a:defRPr>
             </a:pPr>
             <a:r>
-              <a:t>6.6</a:t>
+              <a:t>6.3</a:t>
             </a:r>
           </a:p>
         </p:txBody>
@@ -11187,7 +11187,7 @@
               </a:defRPr>
             </a:pPr>
             <a:r>
-              <a:t>7</a:t>
+              <a:t>6</a:t>
             </a:r>
           </a:p>
         </p:txBody>
@@ -11242,7 +11242,7 @@
               </a:defRPr>
             </a:pPr>
             <a:r>
-              <a:t>7</a:t>
+              <a:t>8</a:t>
             </a:r>
           </a:p>
         </p:txBody>
@@ -11297,7 +11297,7 @@
               </a:defRPr>
             </a:pPr>
             <a:r>
-              <a:t>8</a:t>
+              <a:t>7</a:t>
             </a:r>
           </a:p>
         </p:txBody>
@@ -11462,7 +11462,7 @@
               </a:defRPr>
             </a:pPr>
             <a:r>
-              <a:t>7</a:t>
+              <a:t>6</a:t>
             </a:r>
           </a:p>
         </p:txBody>
@@ -11627,7 +11627,7 @@
               </a:defRPr>
             </a:pPr>
             <a:r>
-              <a:t>Israel</a:t>
+              <a:t>Brazil</a:t>
             </a:r>
           </a:p>
         </p:txBody>
@@ -11682,7 +11682,7 @@
               </a:defRPr>
             </a:pPr>
             <a:r>
-              <a:t>6.3</a:t>
+              <a:t>5.3</a:t>
             </a:r>
           </a:p>
         </p:txBody>
@@ -11737,7 +11737,7 @@
               </a:defRPr>
             </a:pPr>
             <a:r>
-              <a:t>6</a:t>
+              <a:t>7</a:t>
             </a:r>
           </a:p>
         </p:txBody>
@@ -11792,7 +11792,7 @@
               </a:defRPr>
             </a:pPr>
             <a:r>
-              <a:t>8</a:t>
+              <a:t>5</a:t>
             </a:r>
           </a:p>
         </p:txBody>
@@ -11847,7 +11847,7 @@
               </a:defRPr>
             </a:pPr>
             <a:r>
-              <a:t>7</a:t>
+              <a:t>5</a:t>
             </a:r>
           </a:p>
         </p:txBody>
@@ -11902,7 +11902,7 @@
               </a:defRPr>
             </a:pPr>
             <a:r>
-              <a:t>6</a:t>
+              <a:t>5</a:t>
             </a:r>
           </a:p>
         </p:txBody>
@@ -11957,7 +11957,7 @@
               </a:defRPr>
             </a:pPr>
             <a:r>
-              <a:t>6</a:t>
+              <a:t>5</a:t>
             </a:r>
           </a:p>
         </p:txBody>
@@ -12012,7 +12012,7 @@
               </a:defRPr>
             </a:pPr>
             <a:r>
-              <a:t>6</a:t>
+              <a:t>5</a:t>
             </a:r>
           </a:p>
         </p:txBody>
@@ -12122,7 +12122,7 @@
               </a:defRPr>
             </a:pPr>
             <a:r>
-              <a:t>Advanced</a:t>
+              <a:t>Developing</a:t>
             </a:r>
           </a:p>
         </p:txBody>
@@ -14073,7 +14073,7 @@
               </a:defRPr>
             </a:pPr>
             <a:r>
-              <a:t>Sample: 20 jurisdictions · 7 themes · maturity distribution includes 11 Advanced and 2 Early.</a:t>
+              <a:t>Sample: 19 jurisdictions · 7 themes · maturity distribution includes 10 Advanced and 2 Early.</a:t>
             </a:r>
           </a:p>
           <a:p>
@@ -14089,7 +14089,7 @@
               </a:defRPr>
             </a:pPr>
             <a:r>
-              <a:t>Top overall: European Union (9.1), Germany (8.7), United States (7.6).</a:t>
+              <a:t>Top overall: European Union (9.1), United States (7.6), United Kingdom (7.1).</a:t>
             </a:r>
           </a:p>
           <a:p>
@@ -20666,7 +20666,7 @@
               </a:defRPr>
             </a:pPr>
             <a:r>
-              <a:t>Synthesise literature and regulatory texts on AI healthcare compliance across 20 jurisdictions.</a:t>
+              <a:t>Synthesise literature and regulatory texts on AI healthcare compliance across 19 jurisdictions.</a:t>
             </a:r>
           </a:p>
           <a:p>
@@ -21064,7 +21064,7 @@
               </a:defRPr>
             </a:pPr>
             <a:r>
-              <a:t>20 jurisdictions across North America, Europe, Asia, Middle East, Africa, Oceania.</a:t>
+              <a:t>19 jurisdictions across seven regions: North America, Europe, Asia, Middle East, Africa, Oceania, South America.</a:t>
             </a:r>
           </a:p>
         </p:txBody>
@@ -24593,7 +24593,7 @@
               </a:defRPr>
             </a:pPr>
             <a:r>
-              <a:t>11</a:t>
+              <a:t>10</a:t>
             </a:r>
           </a:p>
         </p:txBody>

</xml_diff>

<commit_message>
Add Mexico as 20th non-EU jurisdiction; restore 20-country dataset across report and dashboard.
Co-authored-by: Cursor <cursoragent@cursor.com>
</commit_message>
<xml_diff>
--- a/AI_Clinic_Presentation.pptx
+++ b/AI_Clinic_Presentation.pptx
@@ -14073,7 +14073,7 @@
               </a:defRPr>
             </a:pPr>
             <a:r>
-              <a:t>Sample: 19 jurisdictions · 7 themes · maturity distribution includes 10 Advanced and 2 Early.</a:t>
+              <a:t>Sample: 20 jurisdictions · 7 themes · maturity distribution includes 10 Advanced and 2 Early.</a:t>
             </a:r>
           </a:p>
           <a:p>
@@ -20666,7 +20666,7 @@
               </a:defRPr>
             </a:pPr>
             <a:r>
-              <a:t>Synthesise literature and regulatory texts on AI healthcare compliance across 19 jurisdictions.</a:t>
+              <a:t>Synthesise literature and regulatory texts on AI healthcare compliance across 20 jurisdictions.</a:t>
             </a:r>
           </a:p>
           <a:p>
@@ -21064,7 +21064,7 @@
               </a:defRPr>
             </a:pPr>
             <a:r>
-              <a:t>19 jurisdictions across seven regions: North America, Europe, Asia, Middle East, Africa, Oceania, South America.</a:t>
+              <a:t>20 jurisdictions across seven regions: North America, Europe, Asia, Middle East, Africa, Oceania, South America.</a:t>
             </a:r>
           </a:p>
         </p:txBody>
@@ -24153,7 +24153,7 @@
               </a:defRPr>
             </a:pPr>
             <a:r>
-              <a:t>3</a:t>
+              <a:t>4</a:t>
             </a:r>
           </a:p>
         </p:txBody>

</xml_diff>

<commit_message>
Restore Germany with original profile; remove Mexico from dataset, PDF, and dashboard.
Co-authored-by: Cursor <cursoragent@cursor.com>
</commit_message>
<xml_diff>
--- a/AI_Clinic_Presentation.pptx
+++ b/AI_Clinic_Presentation.pptx
@@ -3692,7 +3692,7 @@
               </a:defRPr>
             </a:pPr>
             <a:r>
-              <a:t>Mean of seven theme scores. EU / United States lead; Kenya and Nigeria trail  -  capacity gap at a glance.</a:t>
+              <a:t>Mean of seven theme scores. EU / Germany / United States lead; Kenya and Nigeria trail  -  capacity gap at a glance.</a:t>
             </a:r>
           </a:p>
         </p:txBody>
@@ -6127,7 +6127,7 @@
               </a:defRPr>
             </a:pPr>
             <a:r>
-              <a:t>United States</a:t>
+              <a:t>Germany</a:t>
             </a:r>
           </a:p>
         </p:txBody>
@@ -6182,7 +6182,7 @@
               </a:defRPr>
             </a:pPr>
             <a:r>
-              <a:t>7.6</a:t>
+              <a:t>8.7</a:t>
             </a:r>
           </a:p>
         </p:txBody>
@@ -6237,7 +6237,7 @@
               </a:defRPr>
             </a:pPr>
             <a:r>
-              <a:t>8</a:t>
+              <a:t>10</a:t>
             </a:r>
           </a:p>
         </p:txBody>
@@ -6402,7 +6402,7 @@
               </a:defRPr>
             </a:pPr>
             <a:r>
-              <a:t>6</a:t>
+              <a:t>8</a:t>
             </a:r>
           </a:p>
         </p:txBody>
@@ -6457,7 +6457,7 @@
               </a:defRPr>
             </a:pPr>
             <a:r>
-              <a:t>6</a:t>
+              <a:t>9</a:t>
             </a:r>
           </a:p>
         </p:txBody>
@@ -6512,7 +6512,7 @@
               </a:defRPr>
             </a:pPr>
             <a:r>
-              <a:t>8</a:t>
+              <a:t>9</a:t>
             </a:r>
           </a:p>
         </p:txBody>
@@ -6677,7 +6677,7 @@
               </a:defRPr>
             </a:pPr>
             <a:r>
-              <a:t>United Kingdom</a:t>
+              <a:t>United States</a:t>
             </a:r>
           </a:p>
         </p:txBody>
@@ -6732,7 +6732,7 @@
               </a:defRPr>
             </a:pPr>
             <a:r>
-              <a:t>7.1</a:t>
+              <a:t>7.6</a:t>
             </a:r>
           </a:p>
         </p:txBody>
@@ -6842,7 +6842,7 @@
               </a:defRPr>
             </a:pPr>
             <a:r>
-              <a:t>8</a:t>
+              <a:t>9</a:t>
             </a:r>
           </a:p>
         </p:txBody>
@@ -6897,7 +6897,7 @@
               </a:defRPr>
             </a:pPr>
             <a:r>
-              <a:t>7</a:t>
+              <a:t>9</a:t>
             </a:r>
           </a:p>
         </p:txBody>
@@ -6952,7 +6952,7 @@
               </a:defRPr>
             </a:pPr>
             <a:r>
-              <a:t>7</a:t>
+              <a:t>6</a:t>
             </a:r>
           </a:p>
         </p:txBody>
@@ -7007,7 +7007,7 @@
               </a:defRPr>
             </a:pPr>
             <a:r>
-              <a:t>7</a:t>
+              <a:t>6</a:t>
             </a:r>
           </a:p>
         </p:txBody>
@@ -7062,7 +7062,7 @@
               </a:defRPr>
             </a:pPr>
             <a:r>
-              <a:t>7</a:t>
+              <a:t>8</a:t>
             </a:r>
           </a:p>
         </p:txBody>
@@ -7117,7 +7117,7 @@
               </a:defRPr>
             </a:pPr>
             <a:r>
-              <a:t>6</a:t>
+              <a:t>7</a:t>
             </a:r>
           </a:p>
         </p:txBody>
@@ -7227,7 +7227,7 @@
               </a:defRPr>
             </a:pPr>
             <a:r>
-              <a:t>Canada</a:t>
+              <a:t>United Kingdom</a:t>
             </a:r>
           </a:p>
         </p:txBody>
@@ -7337,7 +7337,7 @@
               </a:defRPr>
             </a:pPr>
             <a:r>
-              <a:t>7</a:t>
+              <a:t>8</a:t>
             </a:r>
           </a:p>
         </p:txBody>
@@ -7447,7 +7447,7 @@
               </a:defRPr>
             </a:pPr>
             <a:r>
-              <a:t>8</a:t>
+              <a:t>7</a:t>
             </a:r>
           </a:p>
         </p:txBody>
@@ -7777,7 +7777,7 @@
               </a:defRPr>
             </a:pPr>
             <a:r>
-              <a:t>Japan</a:t>
+              <a:t>Canada</a:t>
             </a:r>
           </a:p>
         </p:txBody>
@@ -7832,7 +7832,7 @@
               </a:defRPr>
             </a:pPr>
             <a:r>
-              <a:t>7.0</a:t>
+              <a:t>7.1</a:t>
             </a:r>
           </a:p>
         </p:txBody>
@@ -8052,7 +8052,7 @@
               </a:defRPr>
             </a:pPr>
             <a:r>
-              <a:t>6</a:t>
+              <a:t>7</a:t>
             </a:r>
           </a:p>
         </p:txBody>
@@ -8162,7 +8162,7 @@
               </a:defRPr>
             </a:pPr>
             <a:r>
-              <a:t>8</a:t>
+              <a:t>7</a:t>
             </a:r>
           </a:p>
         </p:txBody>
@@ -8217,7 +8217,7 @@
               </a:defRPr>
             </a:pPr>
             <a:r>
-              <a:t>5</a:t>
+              <a:t>6</a:t>
             </a:r>
           </a:p>
         </p:txBody>
@@ -8327,7 +8327,7 @@
               </a:defRPr>
             </a:pPr>
             <a:r>
-              <a:t>Singapore</a:t>
+              <a:t>Japan</a:t>
             </a:r>
           </a:p>
         </p:txBody>
@@ -8382,7 +8382,7 @@
               </a:defRPr>
             </a:pPr>
             <a:r>
-              <a:t>6.9</a:t>
+              <a:t>7.0</a:t>
             </a:r>
           </a:p>
         </p:txBody>
@@ -8492,7 +8492,7 @@
               </a:defRPr>
             </a:pPr>
             <a:r>
-              <a:t>7</a:t>
+              <a:t>8</a:t>
             </a:r>
           </a:p>
         </p:txBody>
@@ -8547,7 +8547,7 @@
               </a:defRPr>
             </a:pPr>
             <a:r>
-              <a:t>7</a:t>
+              <a:t>8</a:t>
             </a:r>
           </a:p>
         </p:txBody>
@@ -8602,7 +8602,7 @@
               </a:defRPr>
             </a:pPr>
             <a:r>
-              <a:t>8</a:t>
+              <a:t>6</a:t>
             </a:r>
           </a:p>
         </p:txBody>
@@ -8657,7 +8657,7 @@
               </a:defRPr>
             </a:pPr>
             <a:r>
-              <a:t>8</a:t>
+              <a:t>7</a:t>
             </a:r>
           </a:p>
         </p:txBody>
@@ -8712,7 +8712,7 @@
               </a:defRPr>
             </a:pPr>
             <a:r>
-              <a:t>6</a:t>
+              <a:t>8</a:t>
             </a:r>
           </a:p>
         </p:txBody>
@@ -8877,7 +8877,7 @@
               </a:defRPr>
             </a:pPr>
             <a:r>
-              <a:t>Switzerland</a:t>
+              <a:t>Singapore</a:t>
             </a:r>
           </a:p>
         </p:txBody>
@@ -8987,7 +8987,7 @@
               </a:defRPr>
             </a:pPr>
             <a:r>
-              <a:t>8</a:t>
+              <a:t>7</a:t>
             </a:r>
           </a:p>
         </p:txBody>
@@ -9042,7 +9042,7 @@
               </a:defRPr>
             </a:pPr>
             <a:r>
-              <a:t>8</a:t>
+              <a:t>7</a:t>
             </a:r>
           </a:p>
         </p:txBody>
@@ -9097,7 +9097,7 @@
               </a:defRPr>
             </a:pPr>
             <a:r>
-              <a:t>8</a:t>
+              <a:t>7</a:t>
             </a:r>
           </a:p>
         </p:txBody>
@@ -9152,7 +9152,7 @@
               </a:defRPr>
             </a:pPr>
             <a:r>
-              <a:t>6</a:t>
+              <a:t>8</a:t>
             </a:r>
           </a:p>
         </p:txBody>
@@ -9207,7 +9207,7 @@
               </a:defRPr>
             </a:pPr>
             <a:r>
-              <a:t>6</a:t>
+              <a:t>8</a:t>
             </a:r>
           </a:p>
         </p:txBody>
@@ -9262,7 +9262,7 @@
               </a:defRPr>
             </a:pPr>
             <a:r>
-              <a:t>7</a:t>
+              <a:t>6</a:t>
             </a:r>
           </a:p>
         </p:txBody>
@@ -9427,7 +9427,7 @@
               </a:defRPr>
             </a:pPr>
             <a:r>
-              <a:t>China</a:t>
+              <a:t>Switzerland</a:t>
             </a:r>
           </a:p>
         </p:txBody>
@@ -9482,7 +9482,7 @@
               </a:defRPr>
             </a:pPr>
             <a:r>
-              <a:t>6.7</a:t>
+              <a:t>6.9</a:t>
             </a:r>
           </a:p>
         </p:txBody>
@@ -9537,7 +9537,7 @@
               </a:defRPr>
             </a:pPr>
             <a:r>
-              <a:t>7</a:t>
+              <a:t>8</a:t>
             </a:r>
           </a:p>
         </p:txBody>
@@ -9592,7 +9592,7 @@
               </a:defRPr>
             </a:pPr>
             <a:r>
-              <a:t>7</a:t>
+              <a:t>8</a:t>
             </a:r>
           </a:p>
         </p:txBody>
@@ -9647,7 +9647,7 @@
               </a:defRPr>
             </a:pPr>
             <a:r>
-              <a:t>7</a:t>
+              <a:t>8</a:t>
             </a:r>
           </a:p>
         </p:txBody>
@@ -9702,7 +9702,7 @@
               </a:defRPr>
             </a:pPr>
             <a:r>
-              <a:t>7</a:t>
+              <a:t>6</a:t>
             </a:r>
           </a:p>
         </p:txBody>
@@ -9867,7 +9867,7 @@
               </a:defRPr>
             </a:pPr>
             <a:r>
-              <a:t>6</a:t>
+              <a:t>5</a:t>
             </a:r>
           </a:p>
         </p:txBody>
@@ -9977,7 +9977,7 @@
               </a:defRPr>
             </a:pPr>
             <a:r>
-              <a:t>Australia</a:t>
+              <a:t>China</a:t>
             </a:r>
           </a:p>
         </p:txBody>
@@ -10032,7 +10032,7 @@
               </a:defRPr>
             </a:pPr>
             <a:r>
-              <a:t>6.6</a:t>
+              <a:t>6.7</a:t>
             </a:r>
           </a:p>
         </p:txBody>
@@ -10252,7 +10252,7 @@
               </a:defRPr>
             </a:pPr>
             <a:r>
-              <a:t>6</a:t>
+              <a:t>7</a:t>
             </a:r>
           </a:p>
         </p:txBody>
@@ -10307,7 +10307,7 @@
               </a:defRPr>
             </a:pPr>
             <a:r>
-              <a:t>7</a:t>
+              <a:t>6</a:t>
             </a:r>
           </a:p>
         </p:txBody>
@@ -10417,7 +10417,7 @@
               </a:defRPr>
             </a:pPr>
             <a:r>
-              <a:t>5</a:t>
+              <a:t>6</a:t>
             </a:r>
           </a:p>
         </p:txBody>
@@ -10472,7 +10472,7 @@
               </a:defRPr>
             </a:pPr>
             <a:r>
-              <a:t>Moderate</a:t>
+              <a:t>Advanced</a:t>
             </a:r>
           </a:p>
         </p:txBody>
@@ -10527,7 +10527,7 @@
               </a:defRPr>
             </a:pPr>
             <a:r>
-              <a:t>South Korea</a:t>
+              <a:t>Australia</a:t>
             </a:r>
           </a:p>
         </p:txBody>
@@ -10747,7 +10747,7 @@
               </a:defRPr>
             </a:pPr>
             <a:r>
-              <a:t>8</a:t>
+              <a:t>7</a:t>
             </a:r>
           </a:p>
         </p:txBody>
@@ -10857,7 +10857,7 @@
               </a:defRPr>
             </a:pPr>
             <a:r>
-              <a:t>6</a:t>
+              <a:t>7</a:t>
             </a:r>
           </a:p>
         </p:txBody>
@@ -11022,7 +11022,7 @@
               </a:defRPr>
             </a:pPr>
             <a:r>
-              <a:t>Advanced</a:t>
+              <a:t>Moderate</a:t>
             </a:r>
           </a:p>
         </p:txBody>
@@ -11077,7 +11077,7 @@
               </a:defRPr>
             </a:pPr>
             <a:r>
-              <a:t>Israel</a:t>
+              <a:t>South Korea</a:t>
             </a:r>
           </a:p>
         </p:txBody>
@@ -11132,7 +11132,7 @@
               </a:defRPr>
             </a:pPr>
             <a:r>
-              <a:t>6.3</a:t>
+              <a:t>6.6</a:t>
             </a:r>
           </a:p>
         </p:txBody>
@@ -11187,7 +11187,7 @@
               </a:defRPr>
             </a:pPr>
             <a:r>
-              <a:t>6</a:t>
+              <a:t>7</a:t>
             </a:r>
           </a:p>
         </p:txBody>
@@ -11242,7 +11242,7 @@
               </a:defRPr>
             </a:pPr>
             <a:r>
-              <a:t>8</a:t>
+              <a:t>7</a:t>
             </a:r>
           </a:p>
         </p:txBody>
@@ -11297,7 +11297,7 @@
               </a:defRPr>
             </a:pPr>
             <a:r>
-              <a:t>7</a:t>
+              <a:t>8</a:t>
             </a:r>
           </a:p>
         </p:txBody>
@@ -11462,7 +11462,7 @@
               </a:defRPr>
             </a:pPr>
             <a:r>
-              <a:t>6</a:t>
+              <a:t>7</a:t>
             </a:r>
           </a:p>
         </p:txBody>
@@ -11627,7 +11627,7 @@
               </a:defRPr>
             </a:pPr>
             <a:r>
-              <a:t>Brazil</a:t>
+              <a:t>Israel</a:t>
             </a:r>
           </a:p>
         </p:txBody>
@@ -11682,7 +11682,7 @@
               </a:defRPr>
             </a:pPr>
             <a:r>
-              <a:t>5.3</a:t>
+              <a:t>6.3</a:t>
             </a:r>
           </a:p>
         </p:txBody>
@@ -11737,7 +11737,7 @@
               </a:defRPr>
             </a:pPr>
             <a:r>
-              <a:t>7</a:t>
+              <a:t>6</a:t>
             </a:r>
           </a:p>
         </p:txBody>
@@ -11792,7 +11792,7 @@
               </a:defRPr>
             </a:pPr>
             <a:r>
-              <a:t>5</a:t>
+              <a:t>8</a:t>
             </a:r>
           </a:p>
         </p:txBody>
@@ -11847,7 +11847,7 @@
               </a:defRPr>
             </a:pPr>
             <a:r>
-              <a:t>5</a:t>
+              <a:t>7</a:t>
             </a:r>
           </a:p>
         </p:txBody>
@@ -11902,7 +11902,7 @@
               </a:defRPr>
             </a:pPr>
             <a:r>
-              <a:t>5</a:t>
+              <a:t>6</a:t>
             </a:r>
           </a:p>
         </p:txBody>
@@ -11957,7 +11957,7 @@
               </a:defRPr>
             </a:pPr>
             <a:r>
-              <a:t>5</a:t>
+              <a:t>6</a:t>
             </a:r>
           </a:p>
         </p:txBody>
@@ -12012,7 +12012,7 @@
               </a:defRPr>
             </a:pPr>
             <a:r>
-              <a:t>5</a:t>
+              <a:t>6</a:t>
             </a:r>
           </a:p>
         </p:txBody>
@@ -12122,7 +12122,7 @@
               </a:defRPr>
             </a:pPr>
             <a:r>
-              <a:t>Developing</a:t>
+              <a:t>Advanced</a:t>
             </a:r>
           </a:p>
         </p:txBody>
@@ -14073,7 +14073,7 @@
               </a:defRPr>
             </a:pPr>
             <a:r>
-              <a:t>Sample: 20 jurisdictions · 7 themes · maturity distribution includes 10 Advanced and 2 Early.</a:t>
+              <a:t>Sample: 20 jurisdictions · 7 themes · maturity distribution includes 11 Advanced and 2 Early.</a:t>
             </a:r>
           </a:p>
           <a:p>
@@ -14089,7 +14089,7 @@
               </a:defRPr>
             </a:pPr>
             <a:r>
-              <a:t>Top overall: European Union (9.1), United States (7.6), United Kingdom (7.1).</a:t>
+              <a:t>Top overall: European Union (9.1), Germany (8.7), United States (7.6).</a:t>
             </a:r>
           </a:p>
           <a:p>
@@ -24153,7 +24153,7 @@
               </a:defRPr>
             </a:pPr>
             <a:r>
-              <a:t>4</a:t>
+              <a:t>3</a:t>
             </a:r>
           </a:p>
         </p:txBody>
@@ -24593,7 +24593,7 @@
               </a:defRPr>
             </a:pPr>
             <a:r>
-              <a:t>10</a:t>
+              <a:t>11</a:t>
             </a:r>
           </a:p>
         </p:txBody>

</xml_diff>